<commit_message>
feat: migrate data layer from SQLite to BigQuery marts
</commit_message>
<xml_diff>
--- a/data/salidas/reporte_semanal_2026-02-02.pptx
+++ b/data/salidas/reporte_semanal_2026-02-02.pptx
@@ -3899,7 +3899,7 @@
                   <a:srgbClr val="1A1A1A"/>
                 </a:solidFill>
               </a:rPr>
-              <a:t>La región Sureste concentró la mayor actividad noticiosa con 17 artículos, lo que implica un aumento significativo en la visibilidad de la industria y la inversión en esta zona de Coahuila. La actividad noticiosa en las otras regiones, como la Carbonífera con 3 artículos, se enfoca en la generación de empleo, la transición energética y la reconversión industrial, mientras que en el Centro, Norte, Laguna, se centra en la inversión y el desarrollo industrial, destacando la diversidad económica del estado.</a:t>
+              <a:t>La región Sureste concentró la mayor actividad noticiosa con 17 artículos, lo que implica un aumento en la visibilidad de la industria y la inversión en esta zona de Coahuila, destacando el potencial económico y la competitividad de la región. La actividad noticiosa en las demás regiones, como la Carbonífera con 3 artículos que reflejan esfuerzos hacia la transición energética y la reconversión industrial para generar empleo, o la Laguna y el Norte con 9 y 4 artículos respectivamente que sugieren un interés creciente en la inversión y el desarrollo industrial, contribuye a un panorama económico diversificado y dinámico en el estado.</a:t>
             </a:r>
           </a:p>
         </p:txBody>
@@ -4151,7 +4151,7 @@
                   <a:srgbClr val="1A1A1A"/>
                 </a:solidFill>
               </a:rPr>
-              <a:t>  • Alcalde de Torreón entrega nueva plaza en Villas Zaragoza y refuerza recuperación de espac</a:t>
+              <a:t>  • Alcalde de Torreón entrega nueva plaza en Villas Zaragoza y refuerza recuperación de…</a:t>
             </a:r>
           </a:p>
         </p:txBody>
@@ -4294,7 +4294,7 @@
                   <a:srgbClr val="1A1A1A"/>
                 </a:solidFill>
               </a:rPr>
-              <a:t>  • Impulsan empleo y educación en Ramos Arizpe; Grupo Carso generará miles de vacantes por pr</a:t>
+              <a:t>  • Impulsan empleo y educación en Ramos Arizpe; Grupo Carso generará miles de vacantes por…</a:t>
             </a:r>
           </a:p>
         </p:txBody>
@@ -6034,7 +6034,7 @@
                   <a:srgbClr val="1A1A1A"/>
                 </a:solidFill>
               </a:rPr>
-              <a:t>Inversion  37</a:t>
+              <a:t>Inversión  37</a:t>
             </a:r>
           </a:p>
         </p:txBody>
@@ -6274,7 +6274,7 @@
                   <a:srgbClr val="1A1A1A"/>
                 </a:solidFill>
               </a:rPr>
-              <a:t>Energia  18</a:t>
+              <a:t>Energía  18</a:t>
             </a:r>
           </a:p>
         </p:txBody>
@@ -8297,7 +8297,7 @@
                   <a:srgbClr val="FFFFFF"/>
                 </a:solidFill>
               </a:rPr>
-              <a:t>Tema: Inversion</a:t>
+              <a:t>Tema: Inversión</a:t>
             </a:r>
           </a:p>
         </p:txBody>
@@ -9865,7 +9865,7 @@
                   <a:srgbClr val="FFFFFF"/>
                 </a:solidFill>
               </a:rPr>
-              <a:t>Tema: Energia</a:t>
+              <a:t>Tema: Energía</a:t>
             </a:r>
           </a:p>
         </p:txBody>
@@ -12020,7 +12020,7 @@
                   <a:srgbClr val="C00000"/>
                 </a:solidFill>
               </a:rPr>
-              <a:t>● Trump afirma que impondrá nuevos aranceles a Corea del Sur mientras critica los retrasos en el acuerdo comerci</a:t>
+              <a:t>● Trump afirma que impondrá nuevos aranceles a Corea del Sur mientras critica los retrasos en el acuerdo…</a:t>
             </a:r>
           </a:p>
         </p:txBody>

</xml_diff>